<commit_message>
Session 5 round 2: the take-home sheet on screen; Bobby Gore flags closed
The commissioning block now shows the actual take-home sheet across two
slides (the daily rhythm; the four parts), replacing the school-form H5.6
card image - the screen now matches the sheet in the room's hands. The
practice slide's stale card reference reworded. Leader Notes rebuilt from
the 15-slide deck. Pastor Gore's yes closes both open flags: number
phone-verified and after-hours protocol confirmed (launch checklist +
host profile). Adult/mentor note withdrawn by John - not found by either
of us. Deck and Leader Notes re-synced to FotH 2026.

Co-Authored-By: Claude Fable 5 <noreply@anthropic.com>
</commit_message>
<xml_diff>
--- a/_implementation-notes/evening-series/FotH Evening Session 5 Slides DRAFT v1.pptx
+++ b/_implementation-notes/evening-series/FotH Evening Session 5 Slides DRAFT v1.pptx
@@ -19,7 +19,8 @@
     <p:sldId id="366" r:id="rId66"/>
     <p:sldId id="367" r:id="rId67"/>
     <p:sldId id="368" r:id="rId68"/>
-    <p:sldId id="528" r:id="rId69"/>
+    <p:sldId id="530" r:id="rId23"/>
+    <p:sldId id="531" r:id="rId24"/>
     <p:sldId id="369" r:id="rId70"/>
     <p:sldId id="370" r:id="rId71"/>
   </p:sldIdLst>
@@ -822,6 +823,143 @@
 </p:notes>
 </file>
 
+<file path=ppt/notesSlides/notesSlide15.xml><?xml version="1.0" encoding="utf-8"?>
+<p:notes xmlns:a="http://schemas.openxmlformats.org/drawingml/2006/main" xmlns:p="http://schemas.openxmlformats.org/presentationml/2006/main" xmlns:r="http://schemas.openxmlformats.org/officeDocument/2006/relationships">
+  <p:cSld>
+    <p:spTree>
+      <p:nvGrpSpPr>
+        <p:cNvPr id="1" name=""/>
+        <p:cNvGrpSpPr/>
+        <p:nvPr/>
+      </p:nvGrpSpPr>
+      <p:grpSpPr>
+        <a:xfrm>
+          <a:off x="0" y="0"/>
+          <a:ext cx="0" cy="0"/>
+          <a:chOff x="0" y="0"/>
+          <a:chExt cx="0" cy="0"/>
+        </a:xfrm>
+      </p:grpSpPr>
+      <p:sp>
+        <p:nvSpPr>
+          <p:cNvPr id="2" name="Notes Placeholder 1"/>
+          <p:cNvSpPr>
+            <a:spLocks noGrp="1"/>
+          </p:cNvSpPr>
+          <p:nvPr>
+            <p:ph type="body" idx="1"/>
+          </p:nvPr>
+        </p:nvSpPr>
+        <p:spPr/>
+        <p:txBody>
+          <a:bodyPr/>
+          <a:lstStyle/>
+          <a:p>
+            <a:r>
+              <a:t>S5 · 8:20–8:24 · LEAD: CONTENT PRESENTER</a:t>
+            </a:r>
+          </a:p>
+          <a:p>
+            <a:r>
+              <a:t>BEATS:</a:t>
+            </a:r>
+          </a:p>
+          <a:p>
+            <a:r>
+              <a:t>1. The sheet on the screen is the sheet in their hands — walk it, don't read it.</a:t>
+            </a:r>
+          </a:p>
+          <a:p>
+            <a:r>
+              <a:t>2. The standing practice first: the morning question, the evening journal line — every day, both weeks; one box per day on the two week-grids.</a:t>
+            </a:r>
+          </a:p>
+          <a:p>
+            <a:r>
+              <a:t>3. A missed box is never a failure — it is an invitation to return.</a:t>
+            </a:r>
+          </a:p>
+          <a:p>
+            <a:r>
+              <a:t>CUES: Rides inside the commissioning block; the four parts are the next slide.</a:t>
+            </a:r>
+          </a:p>
+        </p:txBody>
+      </p:sp>
+    </p:spTree>
+  </p:cSld>
+  <p:clrMapOvr>
+    <a:masterClrMapping/>
+  </p:clrMapOvr>
+</p:notes>
+</file>
+
+<file path=ppt/notesSlides/notesSlide16.xml><?xml version="1.0" encoding="utf-8"?>
+<p:notes xmlns:a="http://schemas.openxmlformats.org/drawingml/2006/main" xmlns:p="http://schemas.openxmlformats.org/presentationml/2006/main" xmlns:r="http://schemas.openxmlformats.org/officeDocument/2006/relationships">
+  <p:cSld>
+    <p:spTree>
+      <p:nvGrpSpPr>
+        <p:cNvPr id="1" name=""/>
+        <p:cNvGrpSpPr/>
+        <p:nvPr/>
+      </p:nvGrpSpPr>
+      <p:grpSpPr>
+        <a:xfrm>
+          <a:off x="0" y="0"/>
+          <a:ext cx="0" cy="0"/>
+          <a:chOff x="0" y="0"/>
+          <a:chExt cx="0" cy="0"/>
+        </a:xfrm>
+      </p:grpSpPr>
+      <p:sp>
+        <p:nvSpPr>
+          <p:cNvPr id="2" name="Notes Placeholder 1"/>
+          <p:cNvSpPr>
+            <a:spLocks noGrp="1"/>
+          </p:cNvSpPr>
+          <p:nvPr>
+            <p:ph type="body" idx="1"/>
+          </p:nvPr>
+        </p:nvSpPr>
+        <p:spPr/>
+        <p:txBody>
+          <a:bodyPr/>
+          <a:lstStyle/>
+          <a:p>
+            <a:r>
+              <a:t>S5 · 8:20–8:24 · LEAD: CONTENT PRESENTER</a:t>
+            </a:r>
+          </a:p>
+          <a:p>
+            <a:r>
+              <a:t>BEATS:</a:t>
+            </a:r>
+          </a:p>
+          <a:p>
+            <a:r>
+              <a:t>1. The four parts, in order: the homework practice, week one (one friendship, one condition); the end-of-week-one check-in; the homework practice, week two (same friendship, second condition — or deeper); one sentence of preparation.</a:t>
+            </a:r>
+          </a:p>
+          <a:p>
+            <a:r>
+              <a:t>2. Check-in partners are named aloud before leaving this slide — the sheet has the line to write the name.</a:t>
+            </a:r>
+          </a:p>
+          <a:p>
+            <a:r>
+              <a:t>GUARD: Do not reteach the practice here — the practice slide did that; this is the sheet-walk only.</a:t>
+            </a:r>
+          </a:p>
+        </p:txBody>
+      </p:sp>
+    </p:spTree>
+  </p:cSld>
+  <p:clrMapOvr>
+    <a:masterClrMapping/>
+  </p:clrMapOvr>
+</p:notes>
+</file>
+
 <file path=ppt/notesSlides/notesSlide58.xml><?xml version="1.0" encoding="utf-8"?>
 <p:notes xmlns:a="http://schemas.openxmlformats.org/drawingml/2006/main" xmlns:r="http://schemas.openxmlformats.org/officeDocument/2006/relationships" xmlns:p="http://schemas.openxmlformats.org/presentationml/2006/main">
   <p:cSld>
@@ -1464,77 +1602,6 @@
           <a:p>
             <a:r>
               <a:t>4. The homework practice in writing: the Week 5 pages have journal prompts; H5.5 carries the practice. At the end of week one, report to your check-in partner.</a:t>
-            </a:r>
-          </a:p>
-        </p:txBody>
-      </p:sp>
-    </p:spTree>
-  </p:cSld>
-  <p:clrMapOvr>
-    <a:masterClrMapping/>
-  </p:clrMapOvr>
-</p:notes>
-</file>
-
-<file path=ppt/notesSlides/notesSlide67.xml><?xml version="1.0" encoding="utf-8"?>
-<p:notes xmlns:a="http://schemas.openxmlformats.org/drawingml/2006/main" xmlns:r="http://schemas.openxmlformats.org/officeDocument/2006/relationships" xmlns:p="http://schemas.openxmlformats.org/presentationml/2006/main">
-  <p:cSld>
-    <p:spTree>
-      <p:nvGrpSpPr>
-        <p:cNvPr id="1" name=""/>
-        <p:cNvGrpSpPr/>
-        <p:nvPr/>
-      </p:nvGrpSpPr>
-      <p:grpSpPr>
-        <a:xfrm>
-          <a:off x="0" y="0"/>
-          <a:ext cx="0" cy="0"/>
-          <a:chOff x="0" y="0"/>
-          <a:chExt cx="0" cy="0"/>
-        </a:xfrm>
-      </p:grpSpPr>
-      <p:sp>
-        <p:nvSpPr>
-          <p:cNvPr id="2" name="Notes Placeholder 1"/>
-          <p:cNvSpPr>
-            <a:spLocks noGrp="1"/>
-          </p:cNvSpPr>
-          <p:nvPr>
-            <p:ph type="body" idx="1"/>
-          </p:nvPr>
-        </p:nvSpPr>
-        <p:spPr/>
-        <p:txBody>
-          <a:bodyPr/>
-          <a:lstStyle/>
-          <a:p>
-            <a:r>
-              <a:rPr lang="en-US" sz="1200"/>
-              <a:t>S5 · 8:20–8:24 · LEAD: CONTENT PRESENTER</a:t>
-            </a:r>
-          </a:p>
-          <a:p>
-            <a:r>
-              <a:rPr lang="en-US" sz="1200"/>
-              <a:t>BEATS:</a:t>
-            </a:r>
-          </a:p>
-          <a:p>
-            <a:r>
-              <a:rPr lang="en-US" sz="1200"/>
-              <a:t>1. Check-off card (H5.6): daily morning question, evening note, and the one-condition practice; two one-time boxes.</a:t>
-            </a:r>
-          </a:p>
-          <a:p>
-            <a:r>
-              <a:rPr lang="en-US" sz="1200"/>
-              <a:t>2. A missed box is never a failure — it is an invitation to return.</a:t>
-            </a:r>
-          </a:p>
-          <a:p>
-            <a:r>
-              <a:rPr lang="en-US" sz="1200"/>
-              <a:t>CUES: Rides inside the practice block.</a:t>
             </a:r>
           </a:p>
         </p:txBody>
@@ -5406,7 +5473,7 @@
                 </a:solidFill>
                 <a:latin typeface="Calibri"/>
               </a:rPr>
-              <a:t>“One friendship. One condition. Practice. Journal what happens.” — the Session 5 handout carries the card</a:t>
+              <a:t>“One friendship. One condition. Practice. Journal what happens.” — the Session 5 take-home sheet carries it in writing</a:t>
             </a:r>
           </a:p>
           <a:p>
@@ -5505,7 +5572,7 @@
 </file>
 
 <file path=ppt/slides/slide12.xml><?xml version="1.0" encoding="utf-8"?>
-<p:sld xmlns:a="http://schemas.openxmlformats.org/drawingml/2006/main" xmlns:r="http://schemas.openxmlformats.org/officeDocument/2006/relationships" xmlns:p="http://schemas.openxmlformats.org/presentationml/2006/main">
+<p:sld xmlns:a="http://schemas.openxmlformats.org/drawingml/2006/main" xmlns:p="http://schemas.openxmlformats.org/presentationml/2006/main" xmlns:r="http://schemas.openxmlformats.org/officeDocument/2006/relationships">
   <p:cSld>
     <p:spTree>
       <p:nvGrpSpPr>
@@ -5513,14 +5580,7 @@
         <p:cNvGrpSpPr/>
         <p:nvPr/>
       </p:nvGrpSpPr>
-      <p:grpSpPr>
-        <a:xfrm>
-          <a:off x="0" y="0"/>
-          <a:ext cx="0" cy="0"/>
-          <a:chOff x="0" y="0"/>
-          <a:chExt cx="0" cy="0"/>
-        </a:xfrm>
-      </p:grpSpPr>
+      <p:grpSpPr/>
       <p:sp>
         <p:nvSpPr>
           <p:cNvPr id="2" name="Rectangle 1"/>
@@ -5530,7 +5590,7 @@
         <p:spPr>
           <a:xfrm>
             <a:off x="0" y="0"/>
-            <a:ext cx="12191695" cy="6858000"/>
+            <a:ext cx="12192000" cy="6858000"/>
           </a:xfrm>
           <a:prstGeom prst="rect">
             <a:avLst/>
@@ -5541,12 +5601,27 @@
           <a:ln>
             <a:noFill/>
           </a:ln>
+          <a:effectLst/>
         </p:spPr>
-        <p:txBody>
-          <a:bodyPr/>
-          <a:lstStyle/>
-          <a:p>
-            <a:endParaRPr/>
+        <p:style>
+          <a:lnRef idx="1">
+            <a:schemeClr val="accent1"/>
+          </a:lnRef>
+          <a:fillRef idx="3">
+            <a:schemeClr val="accent1"/>
+          </a:fillRef>
+          <a:effectRef idx="2">
+            <a:schemeClr val="accent1"/>
+          </a:effectRef>
+          <a:fontRef idx="minor">
+            <a:schemeClr val="lt1"/>
+          </a:fontRef>
+        </p:style>
+        <p:txBody>
+          <a:bodyPr rtlCol="0" anchor="ctr"/>
+          <a:lstStyle/>
+          <a:p>
+            <a:pPr algn="ctr"/>
           </a:p>
         </p:txBody>
       </p:sp>
@@ -5572,26 +5647,84 @@
           </a:bodyPr>
           <a:lstStyle/>
           <a:p>
-            <a:pPr algn="l">
-              <a:spcAft>
-                <a:spcPts val="600"/>
-              </a:spcAft>
-            </a:pPr>
-            <a:r>
-              <a:rPr sz="2800" b="1" i="0">
+            <a:r>
+              <a:rPr sz="2800" b="1">
                 <a:solidFill>
                   <a:srgbClr val="2C5F2D"/>
                 </a:solidFill>
                 <a:latin typeface="Cambria"/>
               </a:rPr>
-              <a:t>Your Take-Home Card — This Week’s Practice</a:t>
-            </a:r>
-          </a:p>
-        </p:txBody>
-      </p:sp>
-      <p:sp>
-        <p:nvSpPr>
-          <p:cNvPr id="90" name="SlideNum"/>
+              <a:t>The Take-Home Sheet — the Daily Rhythm</a:t>
+            </a:r>
+          </a:p>
+        </p:txBody>
+      </p:sp>
+      <p:pic>
+        <p:nvPicPr>
+          <p:cNvPr id="4" name="Picture 3" descr="s5_sheet_part1.png"/>
+          <p:cNvPicPr>
+            <a:picLocks noChangeAspect="1"/>
+          </p:cNvPicPr>
+          <p:nvPr/>
+        </p:nvPicPr>
+        <p:blipFill>
+          <a:blip r:embed="rId2"/>
+          <a:stretch>
+            <a:fillRect/>
+          </a:stretch>
+        </p:blipFill>
+        <p:spPr>
+          <a:xfrm>
+            <a:off x="1798167" y="1463040"/>
+            <a:ext cx="8595360" cy="4727448"/>
+          </a:xfrm>
+          <a:prstGeom prst="rect">
+            <a:avLst/>
+          </a:prstGeom>
+          <a:ln w="12700">
+            <a:solidFill>
+              <a:srgbClr val="C8C8C8"/>
+            </a:solidFill>
+          </a:ln>
+        </p:spPr>
+      </p:pic>
+      <p:sp>
+        <p:nvSpPr>
+          <p:cNvPr id="5" name="TextBox 4"/>
+          <p:cNvSpPr txBox="1"/>
+          <p:nvPr/>
+        </p:nvSpPr>
+        <p:spPr>
+          <a:xfrm>
+            <a:off x="822960" y="6355080"/>
+            <a:ext cx="10515600" cy="411480"/>
+          </a:xfrm>
+          <a:prstGeom prst="rect">
+            <a:avLst/>
+          </a:prstGeom>
+          <a:noFill/>
+        </p:spPr>
+        <p:txBody>
+          <a:bodyPr wrap="square">
+            <a:spAutoFit/>
+          </a:bodyPr>
+          <a:lstStyle/>
+          <a:p>
+            <a:r>
+              <a:rPr sz="1400" i="1">
+                <a:solidFill>
+                  <a:srgbClr val="595959"/>
+                </a:solidFill>
+                <a:latin typeface="Calibri"/>
+              </a:rPr>
+              <a:t>Handed out now — this is the sheet in your hands.</a:t>
+            </a:r>
+          </a:p>
+        </p:txBody>
+      </p:sp>
+      <p:sp>
+        <p:nvSpPr>
+          <p:cNvPr id="6" name="TextBox 5"/>
           <p:cNvSpPr txBox="1"/>
           <p:nvPr/>
         </p:nvSpPr>
@@ -5606,87 +5739,13 @@
           <a:noFill/>
         </p:spPr>
         <p:txBody>
-          <a:bodyPr wrap="none" lIns="0" tIns="0" rIns="45720" bIns="0" anchor="ctr"/>
-          <a:lstStyle/>
-          <a:p>
-            <a:pPr algn="r"/>
+          <a:bodyPr wrap="none">
+            <a:spAutoFit/>
+          </a:bodyPr>
+          <a:lstStyle/>
+          <a:p>
             <a:r>
               <a:t>68</a:t>
-            </a:r>
-            <a:endParaRPr sz="1000" b="1">
-              <a:solidFill>
-                <a:srgbClr val="7A8A6E"/>
-              </a:solidFill>
-              <a:latin typeface="Calibri"/>
-            </a:endParaRPr>
-          </a:p>
-        </p:txBody>
-      </p:sp>
-      <p:pic>
-        <p:nvPicPr>
-          <p:cNvPr id="270" name="CardImage" descr="the Week 5 check-off card, as handed out"/>
-          <p:cNvPicPr>
-            <a:picLocks noChangeAspect="1"/>
-          </p:cNvPicPr>
-          <p:nvPr/>
-        </p:nvPicPr>
-        <p:blipFill>
-          <a:blip r:embed="rId3"/>
-          <a:stretch>
-            <a:fillRect/>
-          </a:stretch>
-        </p:blipFill>
-        <p:spPr>
-          <a:xfrm>
-            <a:off x="1621175" y="1554480"/>
-            <a:ext cx="8949344" cy="4480560"/>
-          </a:xfrm>
-          <a:prstGeom prst="rect">
-            <a:avLst/>
-          </a:prstGeom>
-          <a:ln w="76200">
-            <a:solidFill>
-              <a:srgbClr val="FFFFFF"/>
-            </a:solidFill>
-          </a:ln>
-          <a:effectLst>
-            <a:outerShdw blurRad="63500" dist="25400" dir="5400000" rotWithShape="0">
-              <a:srgbClr val="000000">
-                <a:alpha val="35000"/>
-              </a:srgbClr>
-            </a:outerShdw>
-          </a:effectLst>
-        </p:spPr>
-      </p:pic>
-      <p:sp>
-        <p:nvSpPr>
-          <p:cNvPr id="271" name="Caption"/>
-          <p:cNvSpPr txBox="1"/>
-          <p:nvPr/>
-        </p:nvSpPr>
-        <p:spPr>
-          <a:xfrm>
-            <a:off x="822960" y="6217920"/>
-            <a:ext cx="10515600" cy="457200"/>
-          </a:xfrm>
-          <a:prstGeom prst="rect">
-            <a:avLst/>
-          </a:prstGeom>
-          <a:noFill/>
-        </p:spPr>
-        <p:txBody>
-          <a:bodyPr wrap="square"/>
-          <a:lstStyle/>
-          <a:p>
-            <a:pPr algn="ctr"/>
-            <a:r>
-              <a:rPr sz="1800" b="0" i="1">
-                <a:solidFill>
-                  <a:srgbClr val="222B22"/>
-                </a:solidFill>
-                <a:latin typeface="Calibri"/>
-              </a:rPr>
-              <a:t>Handed out now — fridge, mirror, journal pocket.</a:t>
             </a:r>
           </a:p>
         </p:txBody>
@@ -5700,6 +5759,165 @@
 </file>
 
 <file path=ppt/slides/slide13.xml><?xml version="1.0" encoding="utf-8"?>
+<p:sld xmlns:a="http://schemas.openxmlformats.org/drawingml/2006/main" xmlns:p="http://schemas.openxmlformats.org/presentationml/2006/main" xmlns:r="http://schemas.openxmlformats.org/officeDocument/2006/relationships">
+  <p:cSld>
+    <p:spTree>
+      <p:nvGrpSpPr>
+        <p:cNvPr id="1" name=""/>
+        <p:cNvGrpSpPr/>
+        <p:nvPr/>
+      </p:nvGrpSpPr>
+      <p:grpSpPr/>
+      <p:sp>
+        <p:nvSpPr>
+          <p:cNvPr id="2" name="Rectangle 1"/>
+          <p:cNvSpPr/>
+          <p:nvPr/>
+        </p:nvSpPr>
+        <p:spPr>
+          <a:xfrm>
+            <a:off x="0" y="0"/>
+            <a:ext cx="12192000" cy="6858000"/>
+          </a:xfrm>
+          <a:prstGeom prst="rect">
+            <a:avLst/>
+          </a:prstGeom>
+          <a:solidFill>
+            <a:srgbClr val="FFFFFF"/>
+          </a:solidFill>
+          <a:ln>
+            <a:noFill/>
+          </a:ln>
+          <a:effectLst/>
+        </p:spPr>
+        <p:style>
+          <a:lnRef idx="1">
+            <a:schemeClr val="accent1"/>
+          </a:lnRef>
+          <a:fillRef idx="3">
+            <a:schemeClr val="accent1"/>
+          </a:fillRef>
+          <a:effectRef idx="2">
+            <a:schemeClr val="accent1"/>
+          </a:effectRef>
+          <a:fontRef idx="minor">
+            <a:schemeClr val="lt1"/>
+          </a:fontRef>
+        </p:style>
+        <p:txBody>
+          <a:bodyPr rtlCol="0" anchor="ctr"/>
+          <a:lstStyle/>
+          <a:p>
+            <a:pPr algn="ctr"/>
+          </a:p>
+        </p:txBody>
+      </p:sp>
+      <p:sp>
+        <p:nvSpPr>
+          <p:cNvPr id="3" name="TextBox 2"/>
+          <p:cNvSpPr txBox="1"/>
+          <p:nvPr/>
+        </p:nvSpPr>
+        <p:spPr>
+          <a:xfrm>
+            <a:off x="822960" y="502920"/>
+            <a:ext cx="10515600" cy="822960"/>
+          </a:xfrm>
+          <a:prstGeom prst="rect">
+            <a:avLst/>
+          </a:prstGeom>
+          <a:noFill/>
+        </p:spPr>
+        <p:txBody>
+          <a:bodyPr wrap="square">
+            <a:spAutoFit/>
+          </a:bodyPr>
+          <a:lstStyle/>
+          <a:p>
+            <a:r>
+              <a:rPr sz="2800" b="1">
+                <a:solidFill>
+                  <a:srgbClr val="2C5F2D"/>
+                </a:solidFill>
+                <a:latin typeface="Cambria"/>
+              </a:rPr>
+              <a:t>The Take-Home Sheet — the Four Parts</a:t>
+            </a:r>
+          </a:p>
+        </p:txBody>
+      </p:sp>
+      <p:sp>
+        <p:nvSpPr>
+          <p:cNvPr id="5" name="TextBox 4"/>
+          <p:cNvSpPr txBox="1"/>
+          <p:nvPr/>
+        </p:nvSpPr>
+        <p:spPr>
+          <a:xfrm>
+            <a:off x="822960" y="6355080"/>
+            <a:ext cx="10515600" cy="411480"/>
+          </a:xfrm>
+          <a:prstGeom prst="rect">
+            <a:avLst/>
+          </a:prstGeom>
+          <a:noFill/>
+        </p:spPr>
+        <p:txBody>
+          <a:bodyPr wrap="square">
+            <a:spAutoFit/>
+          </a:bodyPr>
+          <a:lstStyle/>
+          <a:p>
+            <a:r>
+              <a:rPr sz="1400" i="1">
+                <a:solidFill>
+                  <a:srgbClr val="595959"/>
+                </a:solidFill>
+                <a:latin typeface="Calibri"/>
+              </a:rPr>
+              <a:t>One friendship, one condition — and a partner expecting you at the end of week one.</a:t>
+            </a:r>
+          </a:p>
+        </p:txBody>
+      </p:sp>
+      <p:pic>
+        <p:nvPicPr>
+          <p:cNvPr id="6" name="Picture 5" descr="s5_sheet_part2.png"/>
+          <p:cNvPicPr>
+            <a:picLocks noChangeAspect="1"/>
+          </p:cNvPicPr>
+          <p:nvPr/>
+        </p:nvPicPr>
+        <p:blipFill>
+          <a:blip r:embed="rId4"/>
+          <a:stretch>
+            <a:fillRect/>
+          </a:stretch>
+        </p:blipFill>
+        <p:spPr>
+          <a:xfrm>
+            <a:off x="2483967" y="1463040"/>
+            <a:ext cx="7223760" cy="4721243"/>
+          </a:xfrm>
+          <a:prstGeom prst="rect">
+            <a:avLst/>
+          </a:prstGeom>
+          <a:ln w="12700">
+            <a:solidFill>
+              <a:srgbClr val="C8C8C8"/>
+            </a:solidFill>
+          </a:ln>
+        </p:spPr>
+      </p:pic>
+    </p:spTree>
+  </p:cSld>
+  <p:clrMapOvr>
+    <a:masterClrMapping/>
+  </p:clrMapOvr>
+</p:sld>
+</file>
+
+<file path=ppt/slides/slide14.xml><?xml version="1.0" encoding="utf-8"?>
 <p:sld xmlns:a="http://schemas.openxmlformats.org/drawingml/2006/main" xmlns:r="http://schemas.openxmlformats.org/officeDocument/2006/relationships" xmlns:p="http://schemas.openxmlformats.org/presentationml/2006/main">
   <p:cSld>
     <p:spTree>
@@ -6032,7 +6250,7 @@
 </p:sld>
 </file>
 
-<file path=ppt/slides/slide14.xml><?xml version="1.0" encoding="utf-8"?>
+<file path=ppt/slides/slide15.xml><?xml version="1.0" encoding="utf-8"?>
 <p:sld xmlns:a="http://schemas.openxmlformats.org/drawingml/2006/main" xmlns:r="http://schemas.openxmlformats.org/officeDocument/2006/relationships" xmlns:p="http://schemas.openxmlformats.org/presentationml/2006/main">
   <p:cSld>
     <p:spTree>

</xml_diff>

<commit_message>
Session 5: 'More Than the Four' wrap-up at the merge's tail
New two-minute close from the content presenter after the merge: the four
conditions are foundational - what makes a close friendship possible -
but a good friend also gives you energy, leaves you uplifted, is warm and
caring, maybe even funny. And these are a way to choose which friendships
to deepen with this process and intentionality. New slide (deck now 16),
page table + leads bullet, run sheet table + changes item, leader notes
rebuilt; synced to FotH 2026.

Co-Authored-By: Claude Fable 5 <noreply@anthropic.com>
</commit_message>
<xml_diff>
--- a/_implementation-notes/evening-series/FotH Evening Session 5 Slides DRAFT v1.pptx
+++ b/_implementation-notes/evening-series/FotH Evening Session 5 Slides DRAFT v1.pptx
@@ -18,6 +18,7 @@
     <p:sldId id="365" r:id="rId65"/>
     <p:sldId id="366" r:id="rId66"/>
     <p:sldId id="367" r:id="rId67"/>
+    <p:sldId id="532" r:id="rId21"/>
     <p:sldId id="368" r:id="rId68"/>
     <p:sldId id="530" r:id="rId23"/>
     <p:sldId id="531" r:id="rId24"/>
@@ -752,6 +753,77 @@
 </p:notes>
 </file>
 
+<file path=ppt/notesSlides/notesSlide13.xml><?xml version="1.0" encoding="utf-8"?>
+<p:notes xmlns:a="http://schemas.openxmlformats.org/drawingml/2006/main" xmlns:p="http://schemas.openxmlformats.org/presentationml/2006/main" xmlns:r="http://schemas.openxmlformats.org/officeDocument/2006/relationships">
+  <p:cSld>
+    <p:spTree>
+      <p:nvGrpSpPr>
+        <p:cNvPr id="1" name=""/>
+        <p:cNvGrpSpPr/>
+        <p:nvPr/>
+      </p:nvGrpSpPr>
+      <p:grpSpPr>
+        <a:xfrm>
+          <a:off x="0" y="0"/>
+          <a:ext cx="0" cy="0"/>
+          <a:chOff x="0" y="0"/>
+          <a:chExt cx="0" cy="0"/>
+        </a:xfrm>
+      </p:grpSpPr>
+      <p:sp>
+        <p:nvSpPr>
+          <p:cNvPr id="2" name="Notes Placeholder 1"/>
+          <p:cNvSpPr>
+            <a:spLocks noGrp="1"/>
+          </p:cNvSpPr>
+          <p:nvPr>
+            <p:ph type="body" idx="1"/>
+          </p:nvPr>
+        </p:nvSpPr>
+        <p:spPr/>
+        <p:txBody>
+          <a:bodyPr/>
+          <a:lstStyle/>
+          <a:p>
+            <a:r>
+              <a:t>S5 · 8:18–8:20 · LEAD: CONTENT PRESENTER · WRAP-UP</a:t>
+            </a:r>
+          </a:p>
+          <a:p>
+            <a:r>
+              <a:t>BEATS:</a:t>
+            </a:r>
+          </a:p>
+          <a:p>
+            <a:r>
+              <a:t>1. Name it plainly: the four conditions are foundational — they are what make a close friendship possible. They are not the whole of friendship.</a:t>
+            </a:r>
+          </a:p>
+          <a:p>
+            <a:r>
+              <a:t>2. A good friend also reaches you in other ways: they give you energy — you walk away uplifted; they are warm and caring; maybe even funny.</a:t>
+            </a:r>
+          </a:p>
+          <a:p>
+            <a:r>
+              <a:t>3. Turn it toward choice: these other gifts are a way to think about WHICH friendships you want to deepen — with the process and intentionality we have just walked. As you work your one friendship these two weeks, notice what else your good friendships give you.</a:t>
+            </a:r>
+          </a:p>
+          <a:p>
+            <a:r>
+              <a:t>GUARD: Two minutes, riding the tail of the merge block — not a second teaching. The commissioning needs its time.</a:t>
+            </a:r>
+          </a:p>
+        </p:txBody>
+      </p:sp>
+    </p:spTree>
+  </p:cSld>
+  <p:clrMapOvr>
+    <a:masterClrMapping/>
+  </p:clrMapOvr>
+</p:notes>
+</file>
+
 <file path=ppt/notesSlides/notesSlide14.xml><?xml version="1.0" encoding="utf-8"?>
 <p:notes xmlns:a="http://schemas.openxmlformats.org/drawingml/2006/main" xmlns:p="http://schemas.openxmlformats.org/presentationml/2006/main" xmlns:r="http://schemas.openxmlformats.org/officeDocument/2006/relationships">
   <p:cSld>
@@ -5232,6 +5304,205 @@
 </file>
 
 <file path=ppt/slides/slide11.xml><?xml version="1.0" encoding="utf-8"?>
+<p:sld xmlns:a="http://schemas.openxmlformats.org/drawingml/2006/main" xmlns:p="http://schemas.openxmlformats.org/presentationml/2006/main" xmlns:r="http://schemas.openxmlformats.org/officeDocument/2006/relationships">
+  <p:cSld>
+    <p:spTree>
+      <p:nvGrpSpPr>
+        <p:cNvPr id="1" name=""/>
+        <p:cNvGrpSpPr/>
+        <p:nvPr/>
+      </p:nvGrpSpPr>
+      <p:grpSpPr/>
+      <p:sp>
+        <p:nvSpPr>
+          <p:cNvPr id="2" name="Rectangle 1"/>
+          <p:cNvSpPr/>
+          <p:nvPr/>
+        </p:nvSpPr>
+        <p:spPr>
+          <a:xfrm>
+            <a:off x="0" y="0"/>
+            <a:ext cx="12192000" cy="6858000"/>
+          </a:xfrm>
+          <a:prstGeom prst="rect">
+            <a:avLst/>
+          </a:prstGeom>
+          <a:solidFill>
+            <a:srgbClr val="FFFFFF"/>
+          </a:solidFill>
+          <a:ln>
+            <a:noFill/>
+          </a:ln>
+          <a:effectLst/>
+        </p:spPr>
+        <p:style>
+          <a:lnRef idx="1">
+            <a:schemeClr val="accent1"/>
+          </a:lnRef>
+          <a:fillRef idx="3">
+            <a:schemeClr val="accent1"/>
+          </a:fillRef>
+          <a:effectRef idx="2">
+            <a:schemeClr val="accent1"/>
+          </a:effectRef>
+          <a:fontRef idx="minor">
+            <a:schemeClr val="lt1"/>
+          </a:fontRef>
+        </p:style>
+        <p:txBody>
+          <a:bodyPr rtlCol="0" anchor="ctr"/>
+          <a:lstStyle/>
+          <a:p>
+            <a:pPr algn="ctr"/>
+          </a:p>
+        </p:txBody>
+      </p:sp>
+      <p:sp>
+        <p:nvSpPr>
+          <p:cNvPr id="3" name="TextBox 2"/>
+          <p:cNvSpPr txBox="1"/>
+          <p:nvPr/>
+        </p:nvSpPr>
+        <p:spPr>
+          <a:xfrm>
+            <a:off x="822960" y="502920"/>
+            <a:ext cx="10515600" cy="822960"/>
+          </a:xfrm>
+          <a:prstGeom prst="rect">
+            <a:avLst/>
+          </a:prstGeom>
+          <a:noFill/>
+        </p:spPr>
+        <p:txBody>
+          <a:bodyPr wrap="square">
+            <a:spAutoFit/>
+          </a:bodyPr>
+          <a:lstStyle/>
+          <a:p>
+            <a:r>
+              <a:rPr sz="2800" b="1">
+                <a:solidFill>
+                  <a:srgbClr val="2C5F2D"/>
+                </a:solidFill>
+                <a:latin typeface="Cambria"/>
+              </a:rPr>
+              <a:t>More Than the Four</a:t>
+            </a:r>
+          </a:p>
+        </p:txBody>
+      </p:sp>
+      <p:sp>
+        <p:nvSpPr>
+          <p:cNvPr id="4" name="TextBox 3"/>
+          <p:cNvSpPr txBox="1"/>
+          <p:nvPr/>
+        </p:nvSpPr>
+        <p:spPr>
+          <a:xfrm>
+            <a:off x="822960" y="1645920"/>
+            <a:ext cx="10515600" cy="4206240"/>
+          </a:xfrm>
+          <a:prstGeom prst="rect">
+            <a:avLst/>
+          </a:prstGeom>
+          <a:noFill/>
+        </p:spPr>
+        <p:txBody>
+          <a:bodyPr wrap="square">
+            <a:spAutoFit/>
+          </a:bodyPr>
+          <a:lstStyle/>
+          <a:p>
+            <a:pPr marL="274320" indent="-274320">
+              <a:spcAft>
+                <a:spcPts val="1200"/>
+              </a:spcAft>
+            </a:pPr>
+            <a:r>
+              <a:rPr sz="2000">
+                <a:solidFill>
+                  <a:srgbClr val="222B22"/>
+                </a:solidFill>
+                <a:latin typeface="Calibri"/>
+              </a:rPr>
+              <a:t>•  The four conditions are foundational — they are what make a close friendship possible</a:t>
+            </a:r>
+          </a:p>
+          <a:p>
+            <a:pPr marL="274320" indent="-274320">
+              <a:spcAft>
+                <a:spcPts val="1200"/>
+              </a:spcAft>
+            </a:pPr>
+            <a:r>
+              <a:rPr sz="2000">
+                <a:solidFill>
+                  <a:srgbClr val="222B22"/>
+                </a:solidFill>
+                <a:latin typeface="Calibri"/>
+              </a:rPr>
+              <a:t>•  But a good friend reaches you in more ways than these:</a:t>
+            </a:r>
+          </a:p>
+          <a:p>
+            <a:pPr marL="731520" indent="-274320">
+              <a:spcAft>
+                <a:spcPts val="1200"/>
+              </a:spcAft>
+            </a:pPr>
+            <a:r>
+              <a:rPr sz="2000">
+                <a:solidFill>
+                  <a:srgbClr val="404040"/>
+                </a:solidFill>
+                <a:latin typeface="Calibri"/>
+              </a:rPr>
+              <a:t>–  They give you energy — you walk away from them uplifted</a:t>
+            </a:r>
+          </a:p>
+          <a:p>
+            <a:pPr marL="731520" indent="-274320">
+              <a:spcAft>
+                <a:spcPts val="1200"/>
+              </a:spcAft>
+            </a:pPr>
+            <a:r>
+              <a:rPr sz="2000">
+                <a:solidFill>
+                  <a:srgbClr val="404040"/>
+                </a:solidFill>
+                <a:latin typeface="Calibri"/>
+              </a:rPr>
+              <a:t>–  They are warm and caring — and maybe even funny</a:t>
+            </a:r>
+          </a:p>
+          <a:p>
+            <a:pPr marL="274320" indent="-274320">
+              <a:spcAft>
+                <a:spcPts val="1200"/>
+              </a:spcAft>
+            </a:pPr>
+            <a:r>
+              <a:rPr sz="2000">
+                <a:solidFill>
+                  <a:srgbClr val="222B22"/>
+                </a:solidFill>
+                <a:latin typeface="Calibri"/>
+              </a:rPr>
+              <a:t>•  “And these are a way to choose: which friendships do you want to deepen — with this process, and this intentionality?”</a:t>
+            </a:r>
+          </a:p>
+        </p:txBody>
+      </p:sp>
+    </p:spTree>
+  </p:cSld>
+  <p:clrMapOvr>
+    <a:masterClrMapping/>
+  </p:clrMapOvr>
+</p:sld>
+</file>
+
+<file path=ppt/slides/slide12.xml><?xml version="1.0" encoding="utf-8"?>
 <p:sld xmlns:a="http://schemas.openxmlformats.org/drawingml/2006/main" xmlns:r="http://schemas.openxmlformats.org/officeDocument/2006/relationships" xmlns:p="http://schemas.openxmlformats.org/presentationml/2006/main">
   <p:cSld>
     <p:spTree>
@@ -5571,7 +5842,7 @@
 </p:sld>
 </file>
 
-<file path=ppt/slides/slide12.xml><?xml version="1.0" encoding="utf-8"?>
+<file path=ppt/slides/slide13.xml><?xml version="1.0" encoding="utf-8"?>
 <p:sld xmlns:a="http://schemas.openxmlformats.org/drawingml/2006/main" xmlns:p="http://schemas.openxmlformats.org/presentationml/2006/main" xmlns:r="http://schemas.openxmlformats.org/officeDocument/2006/relationships">
   <p:cSld>
     <p:spTree>
@@ -5758,7 +6029,7 @@
 </p:sld>
 </file>
 
-<file path=ppt/slides/slide13.xml><?xml version="1.0" encoding="utf-8"?>
+<file path=ppt/slides/slide14.xml><?xml version="1.0" encoding="utf-8"?>
 <p:sld xmlns:a="http://schemas.openxmlformats.org/drawingml/2006/main" xmlns:p="http://schemas.openxmlformats.org/presentationml/2006/main" xmlns:r="http://schemas.openxmlformats.org/officeDocument/2006/relationships">
   <p:cSld>
     <p:spTree>
@@ -5917,7 +6188,7 @@
 </p:sld>
 </file>
 
-<file path=ppt/slides/slide14.xml><?xml version="1.0" encoding="utf-8"?>
+<file path=ppt/slides/slide15.xml><?xml version="1.0" encoding="utf-8"?>
 <p:sld xmlns:a="http://schemas.openxmlformats.org/drawingml/2006/main" xmlns:r="http://schemas.openxmlformats.org/officeDocument/2006/relationships" xmlns:p="http://schemas.openxmlformats.org/presentationml/2006/main">
   <p:cSld>
     <p:spTree>
@@ -6250,7 +6521,7 @@
 </p:sld>
 </file>
 
-<file path=ppt/slides/slide15.xml><?xml version="1.0" encoding="utf-8"?>
+<file path=ppt/slides/slide16.xml><?xml version="1.0" encoding="utf-8"?>
 <p:sld xmlns:a="http://schemas.openxmlformats.org/drawingml/2006/main" xmlns:r="http://schemas.openxmlformats.org/officeDocument/2006/relationships" xmlns:p="http://schemas.openxmlformats.org/presentationml/2006/main">
   <p:cSld>
     <p:spTree>

</xml_diff>

<commit_message>
Session 5 deck: formatting repairs from full-deck QA
The paragraphs earlier edits collapsed had inherited the bullet-prefix
styling (moss bold) - rebuilt with proper prefix + body runs on the merge
and practice slides; merge sub-bullets indented; practice slide trimmed
back inside its box (shorter small-number and week-two bullets); road
list given hanging indents so wrapped items align. Leader Notes rebuilt.

Co-Authored-By: Claude Fable 5 <noreply@anthropic.com>
</commit_message>
<xml_diff>
--- a/_implementation-notes/evening-series/FotH Evening Session 5 Slides DRAFT v1.pptx
+++ b/_implementation-notes/evening-series/FotH Evening Session 5 Slides DRAFT v1.pptx
@@ -5175,11 +5175,20 @@
                 </a:solidFill>
                 <a:latin typeface="Calibri"/>
               </a:rPr>
-              <a:t>•  Patterns only — general, no names. Two questions, answered as a pair:</a:t>
-            </a:r>
-          </a:p>
-          <a:p>
-            <a:pPr marL="274320" indent="-274320">
+              <a:t>•  </a:t>
+            </a:r>
+            <a:r>
+              <a:rPr sz="2800" b="0" i="0">
+                <a:solidFill>
+                  <a:srgbClr val="222B22"/>
+                </a:solidFill>
+                <a:latin typeface="Calibri"/>
+              </a:rPr>
+              <a:t>Patterns only — general, no names. Two questions, answered as a pair:</a:t>
+            </a:r>
+          </a:p>
+          <a:p>
+            <a:pPr marL="548640" indent="-274320">
               <a:spcAft>
                 <a:spcPts val="900"/>
               </a:spcAft>
@@ -5191,11 +5200,20 @@
                 </a:solidFill>
                 <a:latin typeface="Calibri"/>
               </a:rPr>
-              <a:t>–  Most common: which condition shows up most often across the friendships we mapped?</a:t>
-            </a:r>
-          </a:p>
-          <a:p>
-            <a:pPr marL="274320" indent="-274320">
+              <a:t>–  </a:t>
+            </a:r>
+            <a:r>
+              <a:rPr sz="2800" b="0" i="0">
+                <a:solidFill>
+                  <a:srgbClr val="222B22"/>
+                </a:solidFill>
+                <a:latin typeface="Calibri"/>
+              </a:rPr>
+              <a:t>Most common: which condition shows up most often across the friendships we mapped?</a:t>
+            </a:r>
+          </a:p>
+          <a:p>
+            <a:pPr marL="548640" indent="-274320">
               <a:spcAft>
                 <a:spcPts val="900"/>
               </a:spcAft>
@@ -5207,7 +5225,16 @@
                 </a:solidFill>
                 <a:latin typeface="Calibri"/>
               </a:rPr>
-              <a:t>–  Rarest: which condition is most often missing?</a:t>
+              <a:t>–  </a:t>
+            </a:r>
+            <a:r>
+              <a:rPr sz="2800" b="0" i="0">
+                <a:solidFill>
+                  <a:srgbClr val="222B22"/>
+                </a:solidFill>
+                <a:latin typeface="Calibri"/>
+              </a:rPr>
+              <a:t>Rarest: which condition is most often missing?</a:t>
             </a:r>
           </a:p>
           <a:p>
@@ -5644,7 +5671,16 @@
                 </a:solidFill>
                 <a:latin typeface="Calibri"/>
               </a:rPr>
-              <a:t>•  We are proposing deep investment in a small number of friendships — starting with one; at this depth, two or three may be all a life can hold</a:t>
+              <a:t>•  </a:t>
+            </a:r>
+            <a:r>
+              <a:rPr sz="2000" b="0" i="0">
+                <a:solidFill>
+                  <a:srgbClr val="222B22"/>
+                </a:solidFill>
+                <a:latin typeface="Calibri"/>
+              </a:rPr>
+              <a:t>Deep investment in a small number of friendships — starting with one; two or three may be all a life can hold</a:t>
             </a:r>
           </a:p>
           <a:p>
@@ -5744,7 +5780,7 @@
                 </a:solidFill>
                 <a:latin typeface="Calibri"/>
               </a:rPr>
-              <a:t>“One friendship. One condition. Practice. Journal what happens.” — the Session 5 take-home sheet carries it in writing</a:t>
+              <a:t>“One friendship. One condition. Practice. Journal what happens.” — the take-home sheet carries it</a:t>
             </a:r>
           </a:p>
           <a:p>
@@ -5760,7 +5796,16 @@
                 </a:solidFill>
                 <a:latin typeface="Calibri"/>
               </a:rPr>
-              <a:t>•  End of week one: report to your check-in partner. Week two: same friendship, second condition — or deeper. The morning and evening questions continue daily</a:t>
+              <a:t>•  </a:t>
+            </a:r>
+            <a:r>
+              <a:rPr sz="2000" b="0" i="0">
+                <a:solidFill>
+                  <a:srgbClr val="222B22"/>
+                </a:solidFill>
+                <a:latin typeface="Calibri"/>
+              </a:rPr>
+              <a:t>End of week one: report to your partner. Week two: second condition — or deeper. The daily questions continue</a:t>
             </a:r>
           </a:p>
         </p:txBody>
@@ -7474,7 +7519,7 @@
           </a:bodyPr>
           <a:lstStyle/>
           <a:p>
-            <a:pPr>
+            <a:pPr marL="274320" indent="-274320">
               <a:spcAft>
                 <a:spcPts val="500"/>
               </a:spcAft>
@@ -7499,7 +7544,7 @@
             </a:r>
           </a:p>
           <a:p>
-            <a:pPr>
+            <a:pPr marL="274320" indent="-274320">
               <a:spcAft>
                 <a:spcPts val="500"/>
               </a:spcAft>
@@ -7524,7 +7569,7 @@
             </a:r>
           </a:p>
           <a:p>
-            <a:pPr>
+            <a:pPr marL="274320" indent="-274320">
               <a:spcAft>
                 <a:spcPts val="500"/>
               </a:spcAft>
@@ -7549,7 +7594,7 @@
             </a:r>
           </a:p>
           <a:p>
-            <a:pPr>
+            <a:pPr marL="274320" indent="-274320">
               <a:spcAft>
                 <a:spcPts val="500"/>
               </a:spcAft>
@@ -7574,7 +7619,7 @@
             </a:r>
           </a:p>
           <a:p>
-            <a:pPr>
+            <a:pPr marL="274320" indent="-274320">
               <a:spcAft>
                 <a:spcPts val="500"/>
               </a:spcAft>
@@ -7599,7 +7644,7 @@
             </a:r>
           </a:p>
           <a:p>
-            <a:pPr>
+            <a:pPr marL="274320" indent="-274320">
               <a:spcAft>
                 <a:spcPts val="500"/>
               </a:spcAft>
@@ -7624,7 +7669,7 @@
             </a:r>
           </a:p>
           <a:p>
-            <a:pPr>
+            <a:pPr marL="274320" indent="-274320">
               <a:spcAft>
                 <a:spcPts val="500"/>
               </a:spcAft>
@@ -7649,7 +7694,7 @@
             </a:r>
           </a:p>
           <a:p>
-            <a:pPr>
+            <a:pPr marL="274320" indent="-274320">
               <a:spcAft>
                 <a:spcPts val="500"/>
               </a:spcAft>
@@ -7674,7 +7719,7 @@
             </a:r>
           </a:p>
           <a:p>
-            <a:pPr>
+            <a:pPr marL="274320" indent="-274320">
               <a:spcAft>
                 <a:spcPts val="500"/>
               </a:spcAft>

</xml_diff>

<commit_message>
Session 5 deck: John's review round
Teaching slide retitled 'Friendship Mapping with Four Conditions';
cluster language settled to pairs throughout (bridge slide, notes) for
timing; small-number line demoted to a sub-bullet; quotes dropped from
the choice line on More Than the Four; interim corner numbers on the
three inserted slides (59a grounding, 66a wrap-up, 68a take-home part 2)
pending the master renumber at the series rebuild. Leader Notes rebuilt.

Co-Authored-By: Claude Fable 5 <noreply@anthropic.com>
</commit_message>
<xml_diff>
--- a/_implementation-notes/evening-series/FotH Evening Session 5 Slides DRAFT v1.pptx
+++ b/_implementation-notes/evening-series/FotH Evening Session 5 Slides DRAFT v1.pptx
@@ -1367,7 +1367,7 @@
           </a:p>
           <a:p>
             <a:r>
-              <a:t>4. Teach lightly — the cluster exercise does the depth work.</a:t>
+              <a:t>4. Teach lightly — the pairs exercise does the depth work.</a:t>
             </a:r>
           </a:p>
           <a:p>
@@ -1438,17 +1438,17 @@
           </a:p>
           <a:p>
             <a:r>
-              <a:t>3. Pray and send: same rooms; back at 8:08. Ten or fewer — stay one circle.</a:t>
-            </a:r>
-          </a:p>
-          <a:p>
-            <a:r>
-              <a:t>SMALL ROOM: the split is only necessary if the room is large enough to need it. With six or so, stay one circle — or drop into quick pair work in place, knee to knee. Pair work is also the standing time-recovery lever: a full split-and-merge costs about five minutes.</a:t>
-            </a:r>
-          </a:p>
-          <a:p>
-            <a:r>
-              <a:t>CUES: In each cluster the Companion goes first on every condition, then the arranged parent opens; teens choose their own depth after; pass anytime.</a:t>
+              <a:t>3. Pray and send: in pairs, right where you sit; back together at 8:08. Ten or fewer can also stay one circle.</a:t>
+            </a:r>
+          </a:p>
+          <a:p>
+            <a:r>
+              <a:t>SMALL ROOM: the split is only necessary if the room is large enough to need it. With six or so, stay one circle — or the quick pair work in place, knee to knee. Pair work is also the standing time-recovery lever: a full split-and-merge costs about five minutes.</a:t>
+            </a:r>
+          </a:p>
+          <a:p>
+            <a:r>
+              <a:t>CUES: A leader models each condition first, then the arranged parent opens; teens choose their own depth after; pass anytime.</a:t>
             </a:r>
           </a:p>
         </p:txBody>
@@ -5516,8 +5516,41 @@
                 </a:solidFill>
                 <a:latin typeface="Calibri"/>
               </a:rPr>
-              <a:t>•  “And these are a way to choose: which friendships do you want to deepen — with this process, and this intentionality?”</a:t>
-            </a:r>
+              <a:t>•  And these are a way to choose: which friendships do you want to deepen — with this process, and this intentionality?</a:t>
+            </a:r>
+          </a:p>
+        </p:txBody>
+      </p:sp>
+      <p:sp>
+        <p:nvSpPr>
+          <p:cNvPr id="90" name="SlideNum"/>
+          <p:cNvSpPr txBox="1"/>
+          <p:nvPr/>
+        </p:nvSpPr>
+        <p:spPr>
+          <a:xfrm>
+            <a:off x="11384280" y="6446520"/>
+            <a:ext cx="640080" cy="292608"/>
+          </a:xfrm>
+          <a:prstGeom prst="rect">
+            <a:avLst/>
+          </a:prstGeom>
+          <a:noFill/>
+        </p:spPr>
+        <p:txBody>
+          <a:bodyPr wrap="none" lIns="0" tIns="0" rIns="45720" bIns="0" anchor="ctr"/>
+          <a:lstStyle/>
+          <a:p>
+            <a:pPr algn="r"/>
+            <a:r>
+              <a:t>66a</a:t>
+            </a:r>
+            <a:endParaRPr sz="1000" b="1">
+              <a:solidFill>
+                <a:srgbClr val="7A8A6E"/>
+              </a:solidFill>
+              <a:latin typeface="Calibri"/>
+            </a:endParaRPr>
           </a:p>
         </p:txBody>
       </p:sp>
@@ -5659,22 +5692,22 @@
             </a:r>
           </a:p>
           <a:p>
-            <a:pPr marL="274320" indent="-274320">
+            <a:pPr marL="685800" indent="-274320">
               <a:spcAft>
-                <a:spcPts val="750"/>
+                <a:spcPts val="550"/>
               </a:spcAft>
             </a:pPr>
             <a:r>
-              <a:rPr sz="2000" b="1" i="0">
+              <a:rPr sz="1800" b="1" i="0">
                 <a:solidFill>
                   <a:srgbClr val="97BC62"/>
                 </a:solidFill>
                 <a:latin typeface="Calibri"/>
               </a:rPr>
-              <a:t>•  </a:t>
-            </a:r>
-            <a:r>
-              <a:rPr sz="2000" b="0" i="0">
+              <a:t>–  </a:t>
+            </a:r>
+            <a:r>
+              <a:rPr sz="1800" b="0" i="1">
                 <a:solidFill>
                   <a:srgbClr val="222B22"/>
                 </a:solidFill>
@@ -6225,6 +6258,39 @@
           </a:ln>
         </p:spPr>
       </p:pic>
+      <p:sp>
+        <p:nvSpPr>
+          <p:cNvPr id="90" name="SlideNum"/>
+          <p:cNvSpPr txBox="1"/>
+          <p:nvPr/>
+        </p:nvSpPr>
+        <p:spPr>
+          <a:xfrm>
+            <a:off x="11384280" y="6446520"/>
+            <a:ext cx="640080" cy="292608"/>
+          </a:xfrm>
+          <a:prstGeom prst="rect">
+            <a:avLst/>
+          </a:prstGeom>
+          <a:noFill/>
+        </p:spPr>
+        <p:txBody>
+          <a:bodyPr wrap="none" lIns="0" tIns="0" rIns="45720" bIns="0" anchor="ctr"/>
+          <a:lstStyle/>
+          <a:p>
+            <a:pPr algn="r"/>
+            <a:r>
+              <a:t>68a</a:t>
+            </a:r>
+            <a:endParaRPr sz="1000" b="1">
+              <a:solidFill>
+                <a:srgbClr val="7A8A6E"/>
+              </a:solidFill>
+              <a:latin typeface="Calibri"/>
+            </a:endParaRPr>
+          </a:p>
+        </p:txBody>
+      </p:sp>
     </p:spTree>
   </p:cSld>
   <p:clrMapOvr>
@@ -7388,6 +7454,39 @@
           </a:p>
         </p:txBody>
       </p:sp>
+      <p:sp>
+        <p:nvSpPr>
+          <p:cNvPr id="90" name="SlideNum"/>
+          <p:cNvSpPr txBox="1"/>
+          <p:nvPr/>
+        </p:nvSpPr>
+        <p:spPr>
+          <a:xfrm>
+            <a:off x="11384280" y="6446520"/>
+            <a:ext cx="640080" cy="292608"/>
+          </a:xfrm>
+          <a:prstGeom prst="rect">
+            <a:avLst/>
+          </a:prstGeom>
+          <a:noFill/>
+        </p:spPr>
+        <p:txBody>
+          <a:bodyPr wrap="none" lIns="0" tIns="0" rIns="45720" bIns="0" anchor="ctr"/>
+          <a:lstStyle/>
+          <a:p>
+            <a:pPr algn="r"/>
+            <a:r>
+              <a:t>59a</a:t>
+            </a:r>
+            <a:endParaRPr sz="1000" b="1">
+              <a:solidFill>
+                <a:srgbClr val="7A8A6E"/>
+              </a:solidFill>
+              <a:latin typeface="Calibri"/>
+            </a:endParaRPr>
+          </a:p>
+        </p:txBody>
+      </p:sp>
     </p:spTree>
   </p:cSld>
   <p:clrMapOvr>
@@ -8532,7 +8631,7 @@
                 </a:solidFill>
                 <a:latin typeface="Cambria"/>
               </a:rPr>
-              <a:t>The Four Conditions</a:t>
+              <a:t>Friendship Mapping with Four Conditions</a:t>
             </a:r>
           </a:p>
         </p:txBody>
@@ -8889,7 +8988,7 @@
                 </a:solidFill>
                 <a:latin typeface="Calibri"/>
               </a:rPr>
-              <a:t>Each cluster takes the four conditions and asks: “for each one, where in my actual friendships does this show up? And where is it missing?”</a:t>
+              <a:t>Each pair takes the four conditions and asks: “for each one, where in my actual friendships does this show up? And where is it missing?”</a:t>
             </a:r>
           </a:p>
           <a:p>
@@ -8939,7 +9038,7 @@
                 </a:solidFill>
                 <a:latin typeface="Calibri"/>
               </a:rPr>
-              <a:t>Your Companion goes first on every condition, then one of the parents opens the round</a:t>
+              <a:t>A leader models each condition first, then one of the parents opens the round</a:t>
             </a:r>
           </a:p>
           <a:p>
@@ -8989,7 +9088,7 @@
                 </a:solidFill>
                 <a:latin typeface="Calibri"/>
               </a:rPr>
-              <a:t>Twenty-eight minutes — same rooms as the last two weeks</a:t>
+              <a:t>Twenty-eight minutes — in pairs, right where you sit</a:t>
             </a:r>
           </a:p>
         </p:txBody>

</xml_diff>

<commit_message>
Session 5 deck: More Than the Four body up to 28pt, matching sibling slides
Co-Authored-By: Claude Fable 5 <noreply@anthropic.com>
</commit_message>
<xml_diff>
--- a/_implementation-notes/evening-series/FotH Evening Session 5 Slides DRAFT v1.pptx
+++ b/_implementation-notes/evening-series/FotH Evening Session 5 Slides DRAFT v1.pptx
@@ -5446,7 +5446,7 @@
               </a:spcAft>
             </a:pPr>
             <a:r>
-              <a:rPr sz="2000">
+              <a:rPr sz="2800">
                 <a:solidFill>
                   <a:srgbClr val="222B22"/>
                 </a:solidFill>
@@ -5462,7 +5462,7 @@
               </a:spcAft>
             </a:pPr>
             <a:r>
-              <a:rPr sz="2000">
+              <a:rPr sz="2800">
                 <a:solidFill>
                   <a:srgbClr val="222B22"/>
                 </a:solidFill>
@@ -5478,7 +5478,7 @@
               </a:spcAft>
             </a:pPr>
             <a:r>
-              <a:rPr sz="2000">
+              <a:rPr sz="2800">
                 <a:solidFill>
                   <a:srgbClr val="404040"/>
                 </a:solidFill>
@@ -5494,7 +5494,7 @@
               </a:spcAft>
             </a:pPr>
             <a:r>
-              <a:rPr sz="2000">
+              <a:rPr sz="2800">
                 <a:solidFill>
                   <a:srgbClr val="404040"/>
                 </a:solidFill>
@@ -5510,7 +5510,7 @@
               </a:spcAft>
             </a:pPr>
             <a:r>
-              <a:rPr sz="2000">
+              <a:rPr sz="2800">
                 <a:solidFill>
                   <a:srgbClr val="222B22"/>
                 </a:solidFill>

</xml_diff>

<commit_message>
Four Connects map: John's flip-chart structure - the conditions hang under Others
Per John's markup on the printed 59a: the four conditions (Safe, Present,
Clear, Intentional) now hang as a sub-bullet under the Others box in the
diagram itself, labeled 'the four conditions of friendship - foundational,
not exhaustive'; and the S5 caption softens 'deepens into' to 'can be a
basis for' loving others, with the foundational-not-exhaustive guard
carried into the S5 page, run sheet, and grounding notes. Image swapped
across all 22 decks; S5 Leader Notes rebuilt; synced to FotH 2026.

Co-Authored-By: Claude Fable 5 <noreply@anthropic.com>
</commit_message>
<xml_diff>
--- a/_implementation-notes/evening-series/FotH Evening Session 5 Slides DRAFT v1.pptx
+++ b/_implementation-notes/evening-series/FotH Evening Session 5 Slides DRAFT v1.pptx
@@ -877,7 +877,7 @@
           </a:p>
           <a:p>
             <a:r>
-              <a:t>3. Tonight makes visible the four conditions that have been quietly holding this room, and asks where they live in our actual friendships. Deeper than connecting: this is how we love others.</a:t>
+              <a:t>3. Tonight makes visible the four conditions that have been quietly holding this room, and asks where they live in our actual friendships. The four conditions can be a basis for loving others — foundational, not exhaustive: there is more to loving somebody than these four (the wrap-up slide names it).</a:t>
             </a:r>
           </a:p>
           <a:p>
@@ -7425,7 +7425,7 @@
                 </a:solidFill>
                 <a:latin typeface="Calibri"/>
               </a:rPr>
-              <a:t>. The four conditions of friendship are how connecting with others deepens into loving others (Matt. 22:37–40).</a:t>
+              <a:t>. The four conditions of friendship are how connecting with others can be a basis for loving others (Matt. 22:37–40).</a:t>
             </a:r>
           </a:p>
         </p:txBody>
@@ -7472,7 +7472,7 @@
           <p:nvPr/>
         </p:nvPicPr>
         <p:blipFill>
-          <a:blip r:embed="rId4"/>
+          <a:blip r:embed="rId5"/>
           <a:stretch>
             <a:fillRect/>
           </a:stretch>

</xml_diff>

<commit_message>
v2.25 (John's word, 8 October): gentler Session 5 take-home (any relationship, offering not testing, an on-ramp if it stirs something hard, gratitude-shaped prep) across sheet, record, run sheet, page and deck; Session 6 Breakout Card (slide 87 on paper, one per group) with print cues in the notes; front page refreshed after the S6 debrief
Co-Authored-By: Claude Opus 5.5 <noreply@anthropic.com>
</commit_message>
<xml_diff>
--- a/_implementation-notes/evening-series/FotH Evening Session 5 Slides DRAFT v1.pptx
+++ b/_implementation-notes/evening-series/FotH Evening Session 5 Slides DRAFT v1.pptx
@@ -1009,7 +1009,7 @@
           </a:p>
           <a:p>
             <a:r>
-              <a:t>1. The four parts, in order: the homework practice, week one (one friendship, one condition); the end-of-week-one check-in; the homework practice, week two (same friendship, second condition — or deeper); one sentence of preparation.</a:t>
+              <a:t>1. The four parts, in order: the homework practice, week one (one relationship, one condition, offered — and the on-ramp if it stirs something hard); the end-of-week-one check-in; the homework practice, week two (same relationship or another, second condition — or deeper); one sentence of preparation.</a:t>
             </a:r>
           </a:p>
           <a:p>
@@ -1658,7 +1658,7 @@
           </a:p>
           <a:p>
             <a:r>
-              <a:t>1. Pick one friendship — yours alone, told to no one. Pick one condition: the most missing, or the hardest to offer.</a:t>
+              <a:t>1. Pick one relationship — a friend, a sibling, a parent, a teammate; not necessarily the closest; yours alone, told to no one. Pick one condition: the most missing, or the hardest to offer.</a:t>
             </a:r>
           </a:p>
           <a:p>
@@ -1668,12 +1668,17 @@
           </a:p>
           <a:p>
             <a:r>
-              <a:t>3. Practice it more intentionally than usual over the two weeks — give the concrete versions: phone in another room for Present; receive without judging for Safe; name a carried thing for Clear; come in watching for what God is doing for Intentional.</a:t>
+              <a:t>3. Practice offering it more intentionally than usual over the two weeks — what you give, not a test of them; how they respond is not a grade on you — give the concrete versions: phone in another room for Present; receive without judging for Safe; name a carried thing for Clear; come in watching for what God is doing for Intentional.</a:t>
             </a:r>
           </a:p>
           <a:p>
             <a:r>
               <a:t>4. The homework practice in writing: the Week 5 pages have journal prompts; H5.5 carries the practice. At the end of week one, report to your check-in partner.</a:t>
+            </a:r>
+          </a:p>
+          <a:p>
+            <a:r>
+              <a:t>5. Say the on-ramp plainly, warmly: looking at friendships can bring up loneliness, a friendship that hurt, or one that faded. Notice it; don't fix it this week. Choose an easier relationship or set the practice down for a few days, and tell someone you trust — your partner, a parent, one of us. The sheet says it too.</a:t>
             </a:r>
           </a:p>
         </p:txBody>
@@ -5642,7 +5647,7 @@
                 </a:solidFill>
                 <a:latin typeface="Cambria"/>
               </a:rPr>
-              <a:t>The Homework Practice — One Friendship, One Condition</a:t>
+              <a:t>The Homework Practice — One Relationship, One Condition</a:t>
             </a:r>
           </a:p>
         </p:txBody>
@@ -5688,7 +5693,7 @@
                 </a:solidFill>
                 <a:latin typeface="Calibri"/>
               </a:rPr>
-              <a:t>“Pick one friendship in your life. Just one.” — you don’t have to tell anyone which one</a:t>
+              <a:t>“Pick one relationship — a friend, a sibling, a parent, a teammate. Just one.” — you don’t have to tell anyone which one</a:t>
             </a:r>
           </a:p>
           <a:p>
@@ -5763,7 +5768,7 @@
                 </a:solidFill>
                 <a:latin typeface="Calibri"/>
               </a:rPr>
-              <a:t>Practice that one condition in that one friendship more intentionally than usual — practically</a:t>
+              <a:t>Practice offering that one condition there, a little more than usual — what you give, not a test of them</a:t>
             </a:r>
           </a:p>
           <a:p>
@@ -5813,7 +5818,7 @@
                 </a:solidFill>
                 <a:latin typeface="Calibri"/>
               </a:rPr>
-              <a:t>“One friendship. One condition. Practice. Journal what happens.” — the take-home sheet carries it</a:t>
+              <a:t>If it stirs something hard: choose an easier one, or set it down for a few days — and tell someone you trust</a:t>
             </a:r>
           </a:p>
           <a:p>
@@ -5838,7 +5843,7 @@
                 </a:solidFill>
                 <a:latin typeface="Calibri"/>
               </a:rPr>
-              <a:t>End of week one: report to your partner. Week two: second condition — or deeper. The daily questions continue</a:t>
+              <a:t>End of week one: report to your partner. Week two: same relationship or another, second condition — or deeper</a:t>
             </a:r>
           </a:p>
         </p:txBody>
@@ -6017,7 +6022,7 @@
           <p:nvPr/>
         </p:nvPicPr>
         <p:blipFill>
-          <a:blip r:embed="rId2"/>
+          <a:blip r:embed="rId4"/>
           <a:stretch>
             <a:fillRect/>
           </a:stretch>
@@ -6025,7 +6030,7 @@
         <p:spPr>
           <a:xfrm>
             <a:off x="1798167" y="1463040"/>
-            <a:ext cx="8595360" cy="4727448"/>
+            <a:ext cx="8595360" cy="3468841"/>
           </a:xfrm>
           <a:prstGeom prst="rect">
             <a:avLst/>
@@ -6224,7 +6229,7 @@
                 </a:solidFill>
                 <a:latin typeface="Calibri"/>
               </a:rPr>
-              <a:t>One friendship, one condition — and a partner expecting you at the end of week one.</a:t>
+              <a:t>One relationship, one condition, offered — and a partner expecting you at the end of week one.</a:t>
             </a:r>
           </a:p>
         </p:txBody>
@@ -6238,15 +6243,15 @@
           <p:nvPr/>
         </p:nvPicPr>
         <p:blipFill>
-          <a:blip r:embed="rId4"/>
+          <a:blip r:embed="rId5"/>
           <a:stretch>
             <a:fillRect/>
           </a:stretch>
         </p:blipFill>
         <p:spPr>
           <a:xfrm>
-            <a:off x="2483967" y="1463040"/>
-            <a:ext cx="7223760" cy="4721243"/>
+            <a:off x="2995594" y="1463040"/>
+            <a:ext cx="6200506" cy="4721243"/>
           </a:xfrm>
           <a:prstGeom prst="rect">
             <a:avLst/>

</xml_diff>